<commit_message>
fix: 三审修复批次 — 可复现性恢复+P1缺陷批+测试补齐+交付物完善 (#867,#868,#869,#871,#872,#880,#881,#882,#883,#884,#874,#875,#876,#830,#829,#835,#842,#847,#849,#768,#858,#860,#807)
P0 可复现性：
- 补回 _invalidate_obs_cache 方法定义（Issue #775 合并时在 merge 冲突解决中丢失）
- 修复 crosstalk 双重扣减回归（还原 #890 修复）
- ruff format 2 文件 + tianyan_client BLE001 → ruff/mypy 清零
- 全量 pytest：276 failed → 0 failed（3593 passed），run_simulation.py 恢复可复现

P0 熔断器：
- #867 before_request HALF_OPEN 单试探控制（对齐 call() 主路径）
- #868 编程错误不计入熔断失败计数

P1 缺陷批：#869 evaluate 禁缓存 / #871 超参校验 / #872 QuotaTracker 负值 / #880 CheckpointManager 加锁 / #881 DQN 超参统一 / #882 Platform 连接释放 / #883 compilation step/reset / #884 DAG 退火超时+QUBO 上限 / #860 MARL 动作3聚合修复+训练稳定性

测试补齐：#876 PPOExplainer / #875 ObsMaskWrapper / #874 统计函数（含手算对照）

交付物：白皮书扩写至 21 页、PPT 旧数字清零（+123.4% 口径）、validate_submission 警告清零、doc-sync 日期检查降 warning、测试数统一 3605、关闭 7 个假 Open issue
</commit_message>
<xml_diff>
--- a/deliverable_models/答辩PPT.pptx
+++ b/deliverable_models/答辩PPT.pptx
@@ -5011,7 +5011,7 @@
               </a:defRPr>
             </a:pPr>
             <a:r>
-              <a:t>  - PPO强化学习实现毫秒级动态决策，+88.3% vs FCFS（p=1.032e-42）</a:t>
+              <a:t>  - PPO强化学习实现毫秒级动态决策，+123.4% vs FCFS（p=1.449e-66）</a:t>
             </a:r>
           </a:p>
           <a:p>
@@ -6129,7 +6129,7 @@
               </a:defRPr>
             </a:pPr>
             <a:r>
-              <a:t>  - Q: 利用率为什么比FCFS低？ A: 帕累托最优权衡（牺牲1.2%利用率换88.3%奖励提升）</a:t>
+              <a:t>  - Q: 利用率为什么比FCFS低？ A: 帕累托最优权衡（牺牲1.2%利用率换123.4%奖励提升）</a:t>
             </a:r>
           </a:p>
           <a:p>
@@ -6547,7 +6547,7 @@
               </a:defRPr>
             </a:pPr>
             <a:r>
-              <a:t>第一层：调度层 — PPO智能调度实时最优分流，+88.3% vs FCFS（N=250, p=1.032e-42）</a:t>
+              <a:t>第一层：调度层 — PPO智能调度实时最优分流，+123.4% vs FCFS（N=250, p=1.449e-66）</a:t>
             </a:r>
           </a:p>
           <a:p>
@@ -6607,7 +6607,7 @@
               </a:defRPr>
             </a:pPr>
             <a:r>
-              <a:t>关键数字：PPO +88.3%、防饥饿0.60 vs 22.00、推理延迟~1ms、315次真机调用100%成功</a:t>
+              <a:t>关键数字：PPO +123.4%、防饥饿0.60 vs 22.00、推理延迟~1ms、315次真机调用100%成功</a:t>
             </a:r>
           </a:p>
         </p:txBody>
@@ -6942,7 +6942,7 @@
               </a:defRPr>
             </a:pPr>
             <a:r>
-              <a:t>PPO策略综合奖励领先：比FCFS提升88.3%</a:t>
+              <a:t>PPO策略综合奖励领先：比FCFS提升123.4%</a:t>
             </a:r>
           </a:p>
         </p:txBody>
@@ -7650,7 +7650,7 @@
               </a:defRPr>
             </a:pPr>
             <a:r>
-              <a:t>帕累托最优权衡：PPO牺牲1.2%利用率换取88.3%总奖励提升（多目标优化合理取舍）</a:t>
+              <a:t>帕累托最优权衡：PPO牺牲1.2%利用率换取123.4%总奖励提升（多目标优化合理取舍）</a:t>
             </a:r>
           </a:p>
         </p:txBody>
@@ -8682,7 +8682,7 @@
               </a:defRPr>
             </a:pPr>
             <a:r>
-              <a:t>  - 等待时间：+6.1%（10seeds，探索性，Issue #532）</a:t>
+              <a:t>  - N=25 配对检验：奖励下降12.43%（Wilcoxon p=2.98e-08, 事后功效1.0）</a:t>
             </a:r>
           </a:p>
           <a:p>
@@ -8697,7 +8697,7 @@
               </a:defRPr>
             </a:pPr>
             <a:r>
-              <a:t>  - 单seed -5.7% 方向相反，待更多数据验证</a:t>
+              <a:t>  - N=25 配对检验：噪声致奖励下降12.43%（Wilcoxon p=2.98e-08, Cohen's d_z=7.71）</a:t>
             </a:r>
           </a:p>
           <a:p>

</xml_diff>

<commit_message>
fix: 8.8外部红队报告核验修复 - P0-1表述/P1-2 ROI/P0-8 PPT/P1-5依赖/P1-6 QEM/P1-8工具链/P1-10双向赋能
核验结论: 7份报告中 R1/R2 基于旧状态(误报); P0-9(脚本硬编码)/P0-7(QA手册)/P1-7(DQN占位)/P2-1(LICENSE)
  实为已修复或误读, 无需改动。

真实修复:
- P0-1(7/7共识): 白皮书3处'策略感知噪声'→'评估对噪声敏感'(实验为评估层对照, 策略不感知)
  并改标题'AI赋能量子'→'量子+AI双向赋能' + 摘要补双向叙事
- P1-2: ROI'30%利用率'误用(实为D4多机协同奖励口径)全仓清除,
  ¥10,950机时节省→不成立(权威利用率-3.3%), 4文档8处+roi脚本/报告同步, 合计¥375,950→¥365,000
- P0-8: PPT退火+6.4%→-5.6%(20seeds), 5种压力场景→4种(数据实际), 真机页标注tianyan176
- P1-5: compilation_env qiskit模块级import→延迟导入(标准环境import不再崩)
- P1-6: SOTA文档'PPO-MLP+QEM'→QEM动作位预留未实现(诚实化)
- P1-8: requirements.lock工具链对齐CI(mypy 1.9→2.1.0, ruff 0.3→0.16.2)
- P1-10: 白皮书标题+摘要补'双向赋能'(0次→3次), PDF重新生成(23页)
- P1-9: 白皮书PDF重新生成(MD/PDF同步)
</commit_message>
<xml_diff>
--- a/deliverable_models/答辩PPT.pptx
+++ b/deliverable_models/答辩PPT.pptx
@@ -4035,7 +4035,7 @@
               </a:defRPr>
             </a:pPr>
             <a:r>
-              <a:t>天衍-287（105数据比特+182耦合比特超导量子计算机）</a:t>
+              <a:t>天衍平台超导量子计算机（目标：天衍-287，105数据比特；历史小样本数据来自 tianyan176 回退）</a:t>
             </a:r>
           </a:p>
         </p:txBody>
@@ -4194,7 +4194,7 @@
                         </a:defRPr>
                       </a:pPr>
                       <a:r>
-                        <a:t>Cohen's d=5.33, p&lt;0.001</a:t>
+                        <a:t>N=10 小样本（历史，tianyan176；d=5.33 探索性）</a:t>
                       </a:r>
                     </a:p>
                   </a:txBody>
@@ -4257,7 +4257,7 @@
                         </a:defRPr>
                       </a:pPr>
                       <a:r>
-                        <a:t>—</a:t>
+                        <a:t>N=10 小样本</a:t>
                       </a:r>
                     </a:p>
                   </a:txBody>
@@ -4324,7 +4324,7 @@
                         </a:defRPr>
                       </a:pPr>
                       <a:r>
-                        <a:t>基线</a:t>
+                        <a:t>N=10 小样本基线</a:t>
                       </a:r>
                     </a:p>
                   </a:txBody>
@@ -4369,7 +4369,7 @@
               </a:defRPr>
             </a:pPr>
             <a:r>
-              <a:t>诚实声明：真机验证主要证明SDK可用性（315次100%成功），性能数字以仿真N=250结果为准</a:t>
+              <a:t>诚实声明：真机验证主要证明SDK可用性（315次100%成功），性能数字以仿真N=250结果为准；上表为小样本探索性数据</a:t>
             </a:r>
           </a:p>
         </p:txBody>
@@ -4503,7 +4503,7 @@
               </a:defRPr>
             </a:pPr>
             <a:r>
-              <a:t>5种压力场景：均衡负载、高负载、量子资源波动、混合潮汐、突发到达</a:t>
+              <a:t>4种压力场景：均衡负载、高负载、量子资源波动、混合潮汐</a:t>
             </a:r>
           </a:p>
           <a:p>
@@ -4518,7 +4518,7 @@
               </a:defRPr>
             </a:pPr>
             <a:r>
-              <a:t>PPO综合稳定性最强：5场景中2次第一、2次第二、1次第三，平均排名1.8</a:t>
+              <a:t>PPO综合稳定性最强：4场景中2次第一、2次第二，平均排名1.8</a:t>
             </a:r>
           </a:p>
           <a:p>
@@ -8861,7 +8861,7 @@
               </a:defRPr>
             </a:pPr>
             <a:r>
-              <a:t>结果：奖励提升+6.4%，p=0.9430（20seeds权威，不显著），训练时间开销+74.5%</a:t>
+              <a:t>结果：奖励变化-5.6%，p=0.9430（20seeds权威，不显著；旧5seed +6.4%已废弃），训练时间开销+74.5%</a:t>
             </a:r>
           </a:p>
           <a:p>

</xml_diff>

<commit_message>
feat+fix: round12收尾 - 真机v3权威(N=20,d=2.11,p=1.22e-07)全仓同步+PDF/PPT重生成 / CI lint修复(ruff+mypy) / reproduce门禁接入pre_freeze / 死链修复 / PPT outline时长 / strategy_comparison旧p值 / env_observation mypy
</commit_message>
<xml_diff>
--- a/deliverable_models/答辩PPT.pptx
+++ b/deliverable_models/答辩PPT.pptx
@@ -4194,7 +4194,7 @@
                         </a:defRPr>
                       </a:pPr>
                       <a:r>
-                        <a:t>N=10 小样本（历史，tianyan176；d=5.33 探索性）</a:t>
+                        <a:t>N=10 小样本（历史，tianyan176；d=2.11 探索性）</a:t>
                       </a:r>
                     </a:p>
                   </a:txBody>
@@ -7162,7 +7162,7 @@
                         </a:defRPr>
                       </a:pPr>
                       <a:r>
-                        <a:t>774.86</a:t>
+                        <a:t>748.48</a:t>
                       </a:r>
                     </a:p>
                   </a:txBody>
@@ -7185,7 +7185,7 @@
                         </a:defRPr>
                       </a:pPr>
                       <a:r>
-                        <a:t>-53.0%</a:t>
+                        <a:t>-54.6%</a:t>
                       </a:r>
                     </a:p>
                   </a:txBody>
@@ -7252,7 +7252,7 @@
                         </a:defRPr>
                       </a:pPr>
                       <a:r>
-                        <a:t>602.37</a:t>
+                        <a:t>697.40</a:t>
                       </a:r>
                     </a:p>
                   </a:txBody>
@@ -7271,7 +7271,7 @@
                         </a:defRPr>
                       </a:pPr>
                       <a:r>
-                        <a:t>-63.5%</a:t>
+                        <a:t>-57.7%</a:t>
                       </a:r>
                     </a:p>
                   </a:txBody>
@@ -7334,7 +7334,7 @@
                         </a:defRPr>
                       </a:pPr>
                       <a:r>
-                        <a:t>80.71</a:t>
+                        <a:t>62.72</a:t>
                       </a:r>
                     </a:p>
                   </a:txBody>
@@ -7357,7 +7357,7 @@
                         </a:defRPr>
                       </a:pPr>
                       <a:r>
-                        <a:t>-95.1%</a:t>
+                        <a:t>-96.2%</a:t>
                       </a:r>
                     </a:p>
                   </a:txBody>

</xml_diff>

<commit_message>
docs: 白皮书§14.2编译层升级N=200权威(+52.1%,p=2.30e-10,d_z=0.54,CI[+43.9%,+72.1%]) + PDF重生成(618KB) + 答辩PPT第11页真机表v3化(1632.26/607.54/782.94,N=20)
</commit_message>
<xml_diff>
--- a/deliverable_models/答辩PPT.pptx
+++ b/deliverable_models/答辩PPT.pptx
@@ -4171,7 +4171,7 @@
                         </a:defRPr>
                       </a:pPr>
                       <a:r>
-                        <a:t>1736.32</a:t>
+                        <a:t>1632.26</a:t>
                       </a:r>
                     </a:p>
                   </a:txBody>
@@ -4194,7 +4194,7 @@
                         </a:defRPr>
                       </a:pPr>
                       <a:r>
-                        <a:t>N=10 小样本（历史，tianyan176；d=2.11 探索性）</a:t>
+                        <a:t>N=20 v3 权威（8.14 扩样；d=2.11, p=1.22e-07）</a:t>
                       </a:r>
                     </a:p>
                   </a:txBody>
@@ -4238,7 +4238,7 @@
                         </a:defRPr>
                       </a:pPr>
                       <a:r>
-                        <a:t>575.33</a:t>
+                        <a:t>607.54</a:t>
                       </a:r>
                     </a:p>
                   </a:txBody>
@@ -4257,7 +4257,7 @@
                         </a:defRPr>
                       </a:pPr>
                       <a:r>
-                        <a:t>N=10 小样本</a:t>
+                        <a:t>N=20 v3 权威</a:t>
                       </a:r>
                     </a:p>
                   </a:txBody>
@@ -4301,7 +4301,7 @@
                         </a:defRPr>
                       </a:pPr>
                       <a:r>
-                        <a:t>383.00</a:t>
+                        <a:t>782.94</a:t>
                       </a:r>
                     </a:p>
                   </a:txBody>
@@ -4324,7 +4324,7 @@
                         </a:defRPr>
                       </a:pPr>
                       <a:r>
-                        <a:t>N=10 小样本基线</a:t>
+                        <a:t>N=20 v3 权威基线</a:t>
                       </a:r>
                     </a:p>
                   </a:txBody>
@@ -4369,7 +4369,7 @@
               </a:defRPr>
             </a:pPr>
             <a:r>
-              <a:t>诚实声明：真机验证主要证明SDK可用性（315次100%成功），性能数字以仿真N=250结果为准；上表为小样本探索性数据</a:t>
+              <a:t>诚实声明：真机验证主要证明SDK可用性（315次100%成功），性能数字以仿真N=250结果为准；上表为混合环境策略对比（96步中仅1步走真机，真机reward占比约1%）</a:t>
             </a:r>
           </a:p>
         </p:txBody>

</xml_diff>

<commit_message>
fix: AgentTeams四路冻结终检P0/P1修复 - 编译层N=200(+52.1%,p=2.30e-10)提交包内自相矛盾清零(PPT P3/P7+总结报告+QA手册6处+novelty/bidirectional/dual_empowerment/observation_dim/MODELS/authoritative_numbers/项目记忆/defense_ppt_outline/defense_narrative/fair_v2横幅共15文件) + 本机路径脱敏(真机补强文档) + 编译N=200原始JSON入库(.gitignore例外,4文件) + 门禁登记6.26e-13与取代披露词 + yaml单侧→双侧标签+std_ddof声明 + PPT/总结报告PDF重生成
</commit_message>
<xml_diff>
--- a/deliverable_models/答辩PPT.pptx
+++ b/deliverable_models/答辩PPT.pptx
@@ -6415,7 +6415,7 @@
               </a:defRPr>
             </a:pPr>
             <a:r>
-              <a:t>第二层：编译层 — PPO替代SABRE比特映射，深电路SWAP减少+38.5%(N=80, Wilcoxon p=2.75e-02，事后子集方向性提示)</a:t>
+              <a:t>第二层：编译层 — PPO替代SABRE比特映射，深电路SWAP减少+52.1%(N=200, Wilcoxon p=2.30e-10，深电路子集强证据)</a:t>
             </a:r>
           </a:p>
           <a:p>
@@ -8236,7 +8236,7 @@
               </a:defRPr>
             </a:pPr>
             <a:r>
-              <a:t>  - 深电路(14-16q) SWAP减少+38.5%（N=80, Wilcoxon p=2.75e-02显著；全60电路p=8.40e-01不显著，诚实披露）</a:t>
+              <a:t>  - 深电路(14-16q) SWAP减少+52.1%（N=200, Wilcoxon p=2.30e-10高度显著；全60电路p=8.40e-01不显著，诚实披露）</a:t>
             </a:r>
           </a:p>
           <a:p>

</xml_diff>